<commit_message>
docs: update presentation slides
</commit_message>
<xml_diff>
--- a/slides.pptx
+++ b/slides.pptx
@@ -130,6 +130,11 @@
       </a:defRPr>
     </a:lvl9pPr>
   </p:defaultTextStyle>
+  <p:extLst>
+    <p:ext uri="{EFAFB233-063F-42B5-8137-9DF3F51BA10A}">
+      <p15:sldGuideLst xmlns:p15="http://schemas.microsoft.com/office/powerpoint/2012/main"/>
+    </p:ext>
+  </p:extLst>
 </p:presentation>
 </file>
 
@@ -17874,16 +17879,76 @@
           <a:p>
             <a:pPr algn="ctr"/>
             <a:r>
-              <a:rPr lang="en-US" sz="1600" b="1">
+              <a:rPr lang="en-US" sz="1600" b="1" dirty="0">
                 <a:solidFill>
                   <a:srgbClr val="B794E6"/>
                 </a:solidFill>
                 <a:latin typeface="Consolas"/>
                 <a:cs typeface="Consolas"/>
               </a:rPr>
-              <a:t>github.com/gbbigardi/meetup-itu-developers-spec-driven-design</a:t>
-            </a:r>
-            <a:endParaRPr lang="en-BR" sz="1600" b="1">
+              <a:t>https://</a:t>
+            </a:r>
+            <a:r>
+              <a:rPr lang="en-US" sz="1600" b="1" dirty="0" err="1">
+                <a:solidFill>
+                  <a:srgbClr val="B794E6"/>
+                </a:solidFill>
+                <a:latin typeface="Consolas"/>
+                <a:cs typeface="Consolas"/>
+              </a:rPr>
+              <a:t>github.com</a:t>
+            </a:r>
+            <a:r>
+              <a:rPr lang="en-US" sz="1600" b="1" dirty="0">
+                <a:solidFill>
+                  <a:srgbClr val="B794E6"/>
+                </a:solidFill>
+                <a:latin typeface="Consolas"/>
+                <a:cs typeface="Consolas"/>
+              </a:rPr>
+              <a:t>/</a:t>
+            </a:r>
+            <a:r>
+              <a:rPr lang="en-US" sz="1600" b="1" dirty="0" err="1">
+                <a:solidFill>
+                  <a:srgbClr val="B794E6"/>
+                </a:solidFill>
+                <a:latin typeface="Consolas"/>
+                <a:cs typeface="Consolas"/>
+              </a:rPr>
+              <a:t>gustavobigardi</a:t>
+            </a:r>
+            <a:r>
+              <a:rPr lang="en-US" sz="1600" b="1" dirty="0">
+                <a:solidFill>
+                  <a:srgbClr val="B794E6"/>
+                </a:solidFill>
+                <a:latin typeface="Consolas"/>
+                <a:cs typeface="Consolas"/>
+              </a:rPr>
+              <a:t>/meetup-</a:t>
+            </a:r>
+            <a:r>
+              <a:rPr lang="en-US" sz="1600" b="1" dirty="0" err="1">
+                <a:solidFill>
+                  <a:srgbClr val="B794E6"/>
+                </a:solidFill>
+                <a:latin typeface="Consolas"/>
+                <a:cs typeface="Consolas"/>
+              </a:rPr>
+              <a:t>itu</a:t>
+            </a:r>
+            <a:r>
+              <a:rPr lang="en-US" sz="1600" b="1" dirty="0">
+                <a:solidFill>
+                  <a:srgbClr val="B794E6"/>
+                </a:solidFill>
+                <a:latin typeface="Consolas"/>
+                <a:cs typeface="Consolas"/>
+              </a:rPr>
+              <a:t>-developers-spec-driven-design</a:t>
+            </a:r>
+            <a:endParaRPr lang="en-BR" sz="1600" b="1" dirty="0">
               <a:solidFill>
                 <a:srgbClr val="B794E6"/>
               </a:solidFill>
@@ -17895,10 +17960,10 @@
       </p:sp>
       <p:pic>
         <p:nvPicPr>
-          <p:cNvPr id="19" name="Picture 18">
-            <a:extLst>
-              <a:ext uri="{FF2B5EF4-FFF2-40B4-BE49-F238E27FC236}">
-                <a16:creationId xmlns:a16="http://schemas.microsoft.com/office/drawing/2014/main" id="{97995B18-79EC-90FA-0EAD-FFE9880AF774}"/>
+          <p:cNvPr id="3" name="Picture 2">
+            <a:extLst>
+              <a:ext uri="{FF2B5EF4-FFF2-40B4-BE49-F238E27FC236}">
+                <a16:creationId xmlns:a16="http://schemas.microsoft.com/office/drawing/2014/main" id="{C81D63AB-9952-134C-4484-7EDF6C15347C}"/>
               </a:ext>
             </a:extLst>
           </p:cNvPr>

</xml_diff>